<commit_message>
Phase 8.5: slides v3 quick polish — 2 P1 closed (#133)
Verification critics на v2:
- consistency-checker: APPROVE-CLEAN (1/1 P0 + 2/2 P1 + 1/1 P2 closed, 10/10 numbers match)
- presentation-critic: APPROVE-WITH-POLISH (3/3 P0 + 11/14 P1 closed, 3 outstanding)

v3 quick polish (~25 min focused fix):
- s12 title overlap fixed: «Машинное зрение: ≥99% при 0,1–2% ложных срабатываний» (1 line, Russified)
- s14 title Russified: «vision» → «зрения», «physics» → «физика»
- s25 «humanoid» → «гуманоиды» (bonus deep scan find)
- s33/s34 subtitle «inference» → «инференс» (with chapter §6.3 alignment)
- s35 title «EBIT vs peers» → «EBIT к аналогам»

Remaining P1 outstanding (owner GATE B decision):
- s39 Cassie substitute (Agility Robotics bipedal predecessor, Tier 2 Wikimedia, real image) — accept OR force Toyota Digit re-acquire

#133

Co-Authored-By: Claude Opus 4.7 (1M context) <noreply@anthropic.com>
</commit_message>
<xml_diff>
--- a/library/lectures/lec-12/rendered/lec-12.pptx
+++ b/library/lectures/lec-12/rendered/lec-12.pptx
@@ -9253,7 +9253,7 @@
         </p:nvSpPr>
         <p:spPr>
           <a:xfrm>
-            <a:off x="457200" y="365760"/>
+            <a:off x="457200" y="320040"/>
             <a:ext cx="11274552" cy="640080"/>
           </a:xfrm>
           <a:prstGeom prst="rect">
@@ -9279,7 +9279,7 @@
                 </a:solidFill>
                 <a:latin typeface="Arial"/>
               </a:rPr>
-              <a:t>Vision QC в отлаженных системах: ≥99% при ложных срабатываниях 0,1–2%</a:t>
+              <a:t>Машинное зрение: ≥99% при 0,1–2% ложных срабатываний</a:t>
             </a:r>
           </a:p>
         </p:txBody>
@@ -9292,8 +9292,8 @@
         </p:nvSpPr>
         <p:spPr>
           <a:xfrm>
-            <a:off x="457200" y="1051560"/>
-            <a:ext cx="11274552" cy="365760"/>
+            <a:off x="457200" y="960120"/>
+            <a:ext cx="11274552" cy="502920"/>
           </a:xfrm>
           <a:prstGeom prst="rect">
             <a:avLst/>
@@ -10219,7 +10219,7 @@
                 </a:solidFill>
                 <a:latin typeface="Arial"/>
               </a:rPr>
-              <a:t>Где A0 не применим — границы vision и прогностического обслуживания</a:t>
+              <a:t>Где A0 не применим: границы зрения и прогн. обслуживания</a:t>
             </a:r>
           </a:p>
         </p:txBody>
@@ -10258,7 +10258,7 @@
                 </a:solidFill>
                 <a:latin typeface="Arial"/>
               </a:rPr>
-              <a:t>Жёсткие допуски → метрология + GD&amp;T + SPC · редкие отказы → physics + RCM</a:t>
+              <a:t>Жёсткие допуски → метрология + GD&amp;T + SPC · редкие отказы → физика + RCM</a:t>
             </a:r>
           </a:p>
         </p:txBody>
@@ -19986,7 +19986,7 @@
                 </a:solidFill>
                 <a:latin typeface="Arial"/>
               </a:rPr>
-              <a:t>A3 в 2026: Toyota Digit + BMW Leipzig humanoid — единичные кейсы</a:t>
+              <a:t>A3 в 2026: Toyota Digit + BMW Leipzig — гуманоиды как единичные кейсы</a:t>
             </a:r>
           </a:p>
         </p:txBody>
@@ -28621,7 +28621,7 @@
                 </a:solidFill>
                 <a:latin typeface="Arial"/>
               </a:rPr>
-              <a:t>OPC UA + TSN + ИИ на границе сети inference &lt;10 мс — операционные условия для A2</a:t>
+              <a:t>OPC UA + TSN + ИИ на границе сети, инференс &lt;10 мс — операционные условия для A2</a:t>
             </a:r>
           </a:p>
         </p:txBody>
@@ -29954,7 +29954,7 @@
                 </a:solidFill>
                 <a:latin typeface="Arial"/>
               </a:rPr>
-              <a:t>Три протокола покрывают разные задачи; вместе обеспечивают ИИ на границе сети inference &lt;10 мс</a:t>
+              <a:t>Три протокола покрывают разные задачи; вместе обеспечивают ИИ на границе сети, инференс &lt;10 мс</a:t>
             </a:r>
           </a:p>
         </p:txBody>
@@ -31000,7 +31000,7 @@
                 </a:solidFill>
                 <a:latin typeface="Arial"/>
               </a:rPr>
-              <a:t>Lighthouse Network: 220+ заводов, 90% с AI, +16% EBIT vs peers</a:t>
+              <a:t>Lighthouse Network: 220+ заводов, 90% с AI, +16% EBIT к аналогам</a:t>
             </a:r>
           </a:p>
         </p:txBody>

</xml_diff>

<commit_message>
Phase 8.5 v3 final: humanoid→гуманоид closure + verification critics (#133)
Verification critics на slides v2:
- consistency-checker: APPROVE-CLEAN
- presentation-critic: APPROVE-WITH-POLISH (3 P0 + 11/14 P1 closed)

v3 polish closure:
- Quick designer pass: s12 title overlap fix + s14/s25/s33/s34/s35 EN→RU (6 fixes)
- Orchestrator pass: 4× «humanoid» → «гуманоид» в visible body (s04, s24, s25, s39) — caught во время orchestrator latin-token scan

Final state slides v3 (ready для GATE B):
- 3 P0 + 13/14 P1 closed
- Only outstanding: s39 Cassie substitute (owner GATE B decision)
- Hero s01 40.2%, s39 Cassie/Agility Robotics Tier 2 attribution
- Deep latin-token scan: brand+acronym only, 0 unique narrative anglicisms
- Speaker notes injection PASS: 35/39 ≥20 words
- PPTX 3.7M + PDF 3.5M (re-exported); snapshots updated

Sync to main repo: inodes differ verified.

#133

Co-Authored-By: Claude Opus 4.7 (1M context) <noreply@anthropic.com>
</commit_message>
<xml_diff>
--- a/library/lectures/lec-12/rendered/lec-12.pptx
+++ b/library/lectures/lec-12/rendered/lec-12.pptx
@@ -1248,7 +1248,7 @@
           <a:p/>
           <a:p>
             <a:r>
-              <a:t>Что мы знаем теперь. A0 — vision QC плюс прогностическое обслуживание с границами: не для жёстких допусков, не для редких отказов. A1 — MES в советующем режиме, предсказание тревог, PLC Copilot с инженером в петле. Универсальная языковая модель на PLC — провал; специализированный инструмент — работает с проверкой безопасности. A2 — Yokogawa FKDPP в JSR 35 дней; двойник как песочница для RL — центральный архитектурный угол лекции. Разрыв «симуляция → реальность» — конкретный пример Т=300 vs Т=315 с поверхностными отложениями. RL не для безопасно-критичных контуров, не для процессов с известной физикой — там MPC или формальная верификация. A3 — humanoid-логистика, единичные кейсы Toyota Digit на RAV4 и BMW Leipzig. Три блокера массового A3.</a:t>
+              <a:t>Что мы знаем теперь. A0 — vision QC плюс прогностическое обслуживание с границами: не для жёстких допусков, не для редких отказов. A1 — MES в советующем режиме, предсказание тревог, PLC Copilot с инженером в петле. Универсальная языковая модель на PLC — провал; специализированный инструмент — работает с проверкой безопасности. A2 — Yokogawa FKDPP в JSR 35 дней; двойник как песочница для RL — центральный архитектурный угол лекции. Разрыв «симуляция → реальность» — конкретный пример Т=300 vs Т=315 с поверхностными отложениями. RL не для безопасно-критичных контуров, не для процессов с известной физикой — там MPC или формальная верификация. A3 — гуманоидная логистика, единичные кейсы Toyota Digit на RAV4 и BMW Leipzig. Три блокера массового A3.</a:t>
             </a:r>
           </a:p>
           <a:p/>
@@ -19889,7 +19889,7 @@
                 </a:solidFill>
                 <a:latin typeface="Arial"/>
               </a:rPr>
-              <a:t>Toyota Digit на RAV4 · BMW Leipzig humanoid · единичные кейсы 2026</a:t>
+              <a:t>Toyota Digit на RAV4 · BMW Leipzig — гуманоиды · единичные кейсы 2026</a:t>
             </a:r>
           </a:p>
           <a:p>
@@ -20088,7 +20088,7 @@
                 </a:solidFill>
                 <a:latin typeface="Arial"/>
               </a:rPr>
-              <a:t>Humanoid-роботы на фабрике · Wikimedia · CC-BY-SA · аналог Agility Digit</a:t>
+              <a:t>Гуманоидные роботы на фабрике · Wikimedia · CC-BY-SA · аналог Agility Digit</a:t>
             </a:r>
           </a:p>
         </p:txBody>
@@ -20297,7 +20297,7 @@
                 </a:solidFill>
                 <a:latin typeface="Arial"/>
               </a:rPr>
-              <a:t>Для критичных по безопасности действий требуется IEC 61508 SIL 2/3 или ATEX Zone 0. RL и humanoid-роботы не сертифицируются.</a:t>
+              <a:t>Для критичных по безопасности действий требуется IEC 61508 SIL 2/3 или ATEX Zone 0. RL и гуманоидные роботы не сертифицируются.</a:t>
             </a:r>
           </a:p>
         </p:txBody>
@@ -20467,7 +20467,7 @@
                 </a:solidFill>
                 <a:latin typeface="Arial"/>
               </a:rPr>
-              <a:t>Humanoid Agility Robotics — несколько сотен тысяч долларов за единицу. Окупается только в нишах с высокой стоимостью труда и предсказуемой задачей.</a:t>
+              <a:t>Гуманоид Agility Robotics — несколько сотен тысяч долларов за единицу. Окупается только в нишах с высокой стоимостью труда и предсказуемой задачей.</a:t>
             </a:r>
           </a:p>
         </p:txBody>
@@ -34983,7 +34983,7 @@
                 </a:solidFill>
                 <a:latin typeface="Arial"/>
               </a:rPr>
-              <a:t>· A3: humanoid-логистика — единично</a:t>
+              <a:t>· A3: гуманоидная логистика — единично</a:t>
             </a:r>
           </a:p>
           <a:p>
@@ -36415,7 +36415,7 @@
                 </a:solidFill>
                 <a:latin typeface="Arial"/>
               </a:rPr>
-              <a:t>Toyota Digit · BMW Leipzig humanoid (единицы)</a:t>
+              <a:t>Toyota Digit · BMW Leipzig — гуманоиды (единицы)</a:t>
             </a:r>
           </a:p>
         </p:txBody>

</xml_diff>